<commit_message>
Name the three presenters on the deck's title and closing slides
Replaces the [ Your name ] / [ phone ] / [ email ] placeholders with
S. Revanth Gopal, Gandra Hemanth Kumar and Sangu Sai Bhargav, each with
their mobile number, under a PRESENTED BY label on slide 1 and across
the closing band on slide 12.

Two things a reader should check rather than assume. The first name is
rendered reading the leading S as an initial; if it is one word the
slide is wrong and a misspelt name is the one error a minister's office
does not forgive. And all three are listed as equals, so nobody reading
this knows whom to call back — naming one as the point of contact would
be better, but which one is not ours to decide.

The ministry line on slide 1 now breaks over three lines so the name
block has room; slide 12's rows tighten by 0.02in each to clear the
taller closing band.

Co-Authored-By: Claude Opus 5 <noreply@anthropic.com>
Claude-Session: https://claude.ai/code/session_015eVLQErbeRapSeA1fFhwwu
</commit_message>
<xml_diff>
--- a/VegDrop-Nara-Lokesh-Deck.pptx
+++ b/VegDrop-Nara-Lokesh-Deck.pptx
@@ -118,37 +118,37 @@
   <p:extLst>
     <p:ext uri="{521415D9-36F7-43E2-AB2F-B90AF26B5E84}">
       <p14:sectionLst xmlns:p14="http://schemas.microsoft.com/office/powerpoint/2010/main">
-        <p14:section name="Opening" id="{a3641e02-641f-ffb7-166b-dfe56069d6a9}">
+        <p14:section name="Opening" id="{ed980f60-d9dd-68e1-cd70-c366f1846a5d}">
           <p14:sldIdLst>
             <p14:sldId id="256"/>
           </p14:sldIdLst>
         </p14:section>
-        <p14:section name="The problem" id="{67ec654e-7766-9f6e-6168-3cb776320c7e}">
+        <p14:section name="The problem" id="{806c2425-e900-c2e4-b35f-bc1005c2a3c6}">
           <p14:sldIdLst>
             <p14:sldId id="257"/>
             <p14:sldId id="258"/>
           </p14:sldIdLst>
         </p14:section>
-        <p14:section name="The product" id="{12bec271-9e62-2b25-c126-8b0a8cf9699a}">
+        <p14:section name="The product" id="{85921e75-087b-f2d3-d8d2-3ca202ca0716}">
           <p14:sldIdLst>
             <p14:sldId id="259"/>
             <p14:sldId id="260"/>
             <p14:sldId id="261"/>
           </p14:sldIdLst>
         </p14:section>
-        <p14:section name="Trust and money" id="{fece0819-24ad-102a-5dbc-c994e984f190}">
+        <p14:section name="Trust and money" id="{c30ad79f-7e59-ab21-0c50-c6618540ae10}">
           <p14:sldIdLst>
             <p14:sldId id="262"/>
             <p14:sldId id="263"/>
           </p14:sldIdLst>
         </p14:section>
-        <p14:section name="Impact" id="{257eaca3-6caa-ef3e-84af-66de4681c40e}">
+        <p14:section name="Impact" id="{95167a4b-6791-3f0b-4aba-70f399a3122f}">
           <p14:sldIdLst>
             <p14:sldId id="264"/>
             <p14:sldId id="265"/>
           </p14:sldIdLst>
         </p14:section>
-        <p14:section name="The ask" id="{3988742f-0487-ebe4-c13d-0ef012973a20}">
+        <p14:section name="The ask" id="{368e0b25-d9ed-6a5d-a4cf-389bd93f9438}">
           <p14:sldIdLst>
             <p14:sldId id="266"/>
             <p14:sldId id="267"/>
@@ -3061,8 +3061,8 @@
         </p:nvSpPr>
         <p:spPr>
           <a:xfrm>
-            <a:off x="640080" y="5486400"/>
-            <a:ext cx="7863840" cy="658368"/>
+            <a:off x="640080" y="5358384"/>
+            <a:ext cx="5852160" cy="914400"/>
           </a:xfrm>
           <a:prstGeom prst="rect">
             <a:avLst/>
@@ -3076,7 +3076,7 @@
           <a:p>
             <a:pPr algn="l" indent="0" marL="0">
               <a:lnSpc>
-                <a:spcPct val="120000"/>
+                <a:spcPct val="118000"/>
               </a:lnSpc>
               <a:buNone/>
             </a:pPr>
@@ -3093,7 +3093,7 @@
           <a:p>
             <a:pPr algn="l" indent="0" marL="0">
               <a:lnSpc>
-                <a:spcPct val="120000"/>
+                <a:spcPct val="118000"/>
               </a:lnSpc>
               <a:buNone/>
             </a:pPr>
@@ -3103,10 +3103,27 @@
                   <a:srgbClr val="97BC62"/>
                 </a:solidFill>
               </a:rPr>
-              <a:t>Minister for IT, Electronics, Communications &amp; HRD, Government of Andhra Pradesh</a:t>
+              <a:t>Minister for IT, Electronics, Communications &amp; HRD,</a:t>
             </a:r>
             <a:endParaRPr lang="en-US" sz="1300" dirty="0"/>
           </a:p>
+          <a:p>
+            <a:pPr algn="l" indent="0" marL="0">
+              <a:lnSpc>
+                <a:spcPct val="118000"/>
+              </a:lnSpc>
+              <a:buNone/>
+            </a:pPr>
+            <a:r>
+              <a:rPr lang="en-US" sz="1300" dirty="0">
+                <a:solidFill>
+                  <a:srgbClr val="97BC62"/>
+                </a:solidFill>
+              </a:rPr>
+              <a:t>Government of Andhra Pradesh</a:t>
+            </a:r>
+            <a:endParaRPr lang="en-US" sz="1300" dirty="0"/>
+          </a:p>
         </p:txBody>
       </p:sp>
       <p:sp>
@@ -3117,8 +3134,44 @@
         </p:nvSpPr>
         <p:spPr>
           <a:xfrm>
-            <a:off x="8778240" y="5486400"/>
-            <a:ext cx="2743200" cy="658368"/>
+            <a:off x="7589520" y="5175504"/>
+            <a:ext cx="3931920" cy="219456"/>
+          </a:xfrm>
+          <a:prstGeom prst="rect">
+            <a:avLst/>
+          </a:prstGeom>
+          <a:noFill/>
+          <a:ln/>
+        </p:spPr>
+        <p:txBody>
+          <a:bodyPr wrap="square" lIns="0" tIns="0" rIns="0" bIns="0" rtlCol="0" anchor="ctr"/>
+          <a:lstStyle/>
+          <a:p>
+            <a:pPr algn="r" indent="0" marL="0">
+              <a:buNone/>
+            </a:pPr>
+            <a:r>
+              <a:rPr lang="en-US" sz="900" b="1" spc="200" kern="0" dirty="0">
+                <a:solidFill>
+                  <a:srgbClr val="6E7F6E"/>
+                </a:solidFill>
+              </a:rPr>
+              <a:t>PRESENTED BY</a:t>
+            </a:r>
+            <a:endParaRPr lang="en-US" sz="900" dirty="0"/>
+          </a:p>
+        </p:txBody>
+      </p:sp>
+      <p:sp>
+        <p:nvSpPr>
+          <p:cNvPr id="14" name="Text 12"/>
+          <p:cNvSpPr txBox="1"/>
+          <p:nvPr/>
+        </p:nvSpPr>
+        <p:spPr>
+          <a:xfrm>
+            <a:off x="7589520" y="5394960"/>
+            <a:ext cx="3931920" cy="877824"/>
           </a:xfrm>
           <a:prstGeom prst="rect">
             <a:avLst/>
@@ -3132,7 +3185,7 @@
           <a:p>
             <a:pPr algn="r" indent="0" marL="0">
               <a:lnSpc>
-                <a:spcPct val="120000"/>
+                <a:spcPct val="122000"/>
               </a:lnSpc>
               <a:buNone/>
             </a:pPr>
@@ -3142,24 +3195,125 @@
                   <a:srgbClr val="FFFFFF"/>
                 </a:solidFill>
               </a:rPr>
-              <a:t>[ Your name ]</a:t>
-            </a:r>
-            <a:endParaRPr lang="en-US" sz="1150" dirty="0"/>
-          </a:p>
-          <a:p>
+              <a:t>S. Revanth Gopal</a:t>
+            </a:r>
             <a:pPr algn="r" indent="0" marL="0">
               <a:lnSpc>
-                <a:spcPct val="120000"/>
+                <a:spcPct val="122000"/>
               </a:lnSpc>
               <a:buNone/>
             </a:pPr>
             <a:r>
               <a:rPr lang="en-US" sz="1150" dirty="0">
                 <a:solidFill>
+                  <a:srgbClr val="6E7F6E"/>
+                </a:solidFill>
+              </a:rPr>
+              <a:t>   ·   </a:t>
+            </a:r>
+            <a:pPr algn="r" indent="0" marL="0">
+              <a:lnSpc>
+                <a:spcPct val="122000"/>
+              </a:lnSpc>
+              <a:buNone/>
+            </a:pPr>
+            <a:r>
+              <a:rPr lang="en-US" sz="1150" dirty="0">
+                <a:solidFill>
                   <a:srgbClr val="97BC62"/>
                 </a:solidFill>
               </a:rPr>
-              <a:t>[ phone ]  ·  [ email ]</a:t>
+              <a:t>94414 88911</a:t>
+            </a:r>
+            <a:endParaRPr lang="en-US" sz="1150" dirty="0"/>
+          </a:p>
+          <a:p>
+            <a:pPr algn="r" indent="0" marL="0">
+              <a:lnSpc>
+                <a:spcPct val="122000"/>
+              </a:lnSpc>
+              <a:buNone/>
+            </a:pPr>
+            <a:r>
+              <a:rPr lang="en-US" sz="1150" b="1" dirty="0">
+                <a:solidFill>
+                  <a:srgbClr val="FFFFFF"/>
+                </a:solidFill>
+              </a:rPr>
+              <a:t>Gandra Hemanth Kumar</a:t>
+            </a:r>
+            <a:pPr algn="r" indent="0" marL="0">
+              <a:lnSpc>
+                <a:spcPct val="122000"/>
+              </a:lnSpc>
+              <a:buNone/>
+            </a:pPr>
+            <a:r>
+              <a:rPr lang="en-US" sz="1150" dirty="0">
+                <a:solidFill>
+                  <a:srgbClr val="6E7F6E"/>
+                </a:solidFill>
+              </a:rPr>
+              <a:t>   ·   </a:t>
+            </a:r>
+            <a:pPr algn="r" indent="0" marL="0">
+              <a:lnSpc>
+                <a:spcPct val="122000"/>
+              </a:lnSpc>
+              <a:buNone/>
+            </a:pPr>
+            <a:r>
+              <a:rPr lang="en-US" sz="1150" dirty="0">
+                <a:solidFill>
+                  <a:srgbClr val="97BC62"/>
+                </a:solidFill>
+              </a:rPr>
+              <a:t>97055 41348</a:t>
+            </a:r>
+            <a:endParaRPr lang="en-US" sz="1150" dirty="0"/>
+          </a:p>
+          <a:p>
+            <a:pPr algn="r" indent="0" marL="0">
+              <a:lnSpc>
+                <a:spcPct val="122000"/>
+              </a:lnSpc>
+              <a:buNone/>
+            </a:pPr>
+            <a:r>
+              <a:rPr lang="en-US" sz="1150" b="1" dirty="0">
+                <a:solidFill>
+                  <a:srgbClr val="FFFFFF"/>
+                </a:solidFill>
+              </a:rPr>
+              <a:t>Sangu Sai Bhargav</a:t>
+            </a:r>
+            <a:pPr algn="r" indent="0" marL="0">
+              <a:lnSpc>
+                <a:spcPct val="122000"/>
+              </a:lnSpc>
+              <a:buNone/>
+            </a:pPr>
+            <a:r>
+              <a:rPr lang="en-US" sz="1150" dirty="0">
+                <a:solidFill>
+                  <a:srgbClr val="6E7F6E"/>
+                </a:solidFill>
+              </a:rPr>
+              <a:t>   ·   </a:t>
+            </a:r>
+            <a:pPr algn="r" indent="0" marL="0">
+              <a:lnSpc>
+                <a:spcPct val="122000"/>
+              </a:lnSpc>
+              <a:buNone/>
+            </a:pPr>
+            <a:r>
+              <a:rPr lang="en-US" sz="1150" dirty="0">
+                <a:solidFill>
+                  <a:srgbClr val="97BC62"/>
+                </a:solidFill>
+              </a:rPr>
+              <a:t>90145 51801</a:t>
             </a:r>
             <a:endParaRPr lang="en-US" sz="1150" dirty="0"/>
           </a:p>
@@ -4792,7 +4946,7 @@
         </p:nvSpPr>
         <p:spPr>
           <a:xfrm>
-            <a:off x="640080" y="1225296"/>
+            <a:off x="640080" y="1170432"/>
             <a:ext cx="10881360" cy="292608"/>
           </a:xfrm>
           <a:prstGeom prst="rect">
@@ -4828,12 +4982,12 @@
         </p:nvSpPr>
         <p:spPr>
           <a:xfrm>
-            <a:off x="640080" y="1627632"/>
-            <a:ext cx="10881360" cy="694944"/>
+            <a:off x="640080" y="1554480"/>
+            <a:ext cx="10881360" cy="640080"/>
           </a:xfrm>
           <a:prstGeom prst="roundRect">
             <a:avLst>
-              <a:gd name="adj" fmla="val 5263"/>
+              <a:gd name="adj" fmla="val 5714"/>
             </a:avLst>
           </a:prstGeom>
           <a:solidFill>
@@ -4857,8 +5011,8 @@
         </p:nvSpPr>
         <p:spPr>
           <a:xfrm>
-            <a:off x="969264" y="1627632"/>
-            <a:ext cx="658368" cy="694944"/>
+            <a:off x="969264" y="1554480"/>
+            <a:ext cx="658368" cy="640080"/>
           </a:xfrm>
           <a:prstGeom prst="rect">
             <a:avLst/>
@@ -4893,8 +5047,8 @@
         </p:nvSpPr>
         <p:spPr>
           <a:xfrm>
-            <a:off x="1645920" y="1627632"/>
-            <a:ext cx="4572000" cy="694944"/>
+            <a:off x="1645920" y="1554480"/>
+            <a:ext cx="4572000" cy="640080"/>
           </a:xfrm>
           <a:prstGeom prst="rect">
             <a:avLst/>
@@ -4929,8 +5083,8 @@
         </p:nvSpPr>
         <p:spPr>
           <a:xfrm>
-            <a:off x="6400800" y="1627632"/>
-            <a:ext cx="4754880" cy="694944"/>
+            <a:off x="6400800" y="1554480"/>
+            <a:ext cx="4754880" cy="640080"/>
           </a:xfrm>
           <a:prstGeom prst="rect">
             <a:avLst/>
@@ -4965,12 +5119,12 @@
         </p:nvSpPr>
         <p:spPr>
           <a:xfrm>
-            <a:off x="640080" y="2395728"/>
-            <a:ext cx="10881360" cy="694944"/>
+            <a:off x="640080" y="2267712"/>
+            <a:ext cx="10881360" cy="640080"/>
           </a:xfrm>
           <a:prstGeom prst="roundRect">
             <a:avLst>
-              <a:gd name="adj" fmla="val 5263"/>
+              <a:gd name="adj" fmla="val 5714"/>
             </a:avLst>
           </a:prstGeom>
           <a:solidFill>
@@ -4994,8 +5148,8 @@
         </p:nvSpPr>
         <p:spPr>
           <a:xfrm>
-            <a:off x="969264" y="2395728"/>
-            <a:ext cx="658368" cy="694944"/>
+            <a:off x="969264" y="2267712"/>
+            <a:ext cx="658368" cy="640080"/>
           </a:xfrm>
           <a:prstGeom prst="rect">
             <a:avLst/>
@@ -5030,8 +5184,8 @@
         </p:nvSpPr>
         <p:spPr>
           <a:xfrm>
-            <a:off x="1645920" y="2395728"/>
-            <a:ext cx="4572000" cy="694944"/>
+            <a:off x="1645920" y="2267712"/>
+            <a:ext cx="4572000" cy="640080"/>
           </a:xfrm>
           <a:prstGeom prst="rect">
             <a:avLst/>
@@ -5066,8 +5220,8 @@
         </p:nvSpPr>
         <p:spPr>
           <a:xfrm>
-            <a:off x="6400800" y="2395728"/>
-            <a:ext cx="4754880" cy="694944"/>
+            <a:off x="6400800" y="2267712"/>
+            <a:ext cx="4754880" cy="640080"/>
           </a:xfrm>
           <a:prstGeom prst="rect">
             <a:avLst/>
@@ -5102,12 +5256,12 @@
         </p:nvSpPr>
         <p:spPr>
           <a:xfrm>
-            <a:off x="640080" y="3163824"/>
-            <a:ext cx="10881360" cy="694944"/>
+            <a:off x="640080" y="2980944"/>
+            <a:ext cx="10881360" cy="640080"/>
           </a:xfrm>
           <a:prstGeom prst="roundRect">
             <a:avLst>
-              <a:gd name="adj" fmla="val 5263"/>
+              <a:gd name="adj" fmla="val 5714"/>
             </a:avLst>
           </a:prstGeom>
           <a:solidFill>
@@ -5131,8 +5285,8 @@
         </p:nvSpPr>
         <p:spPr>
           <a:xfrm>
-            <a:off x="969264" y="3163824"/>
-            <a:ext cx="658368" cy="694944"/>
+            <a:off x="969264" y="2980944"/>
+            <a:ext cx="658368" cy="640080"/>
           </a:xfrm>
           <a:prstGeom prst="rect">
             <a:avLst/>
@@ -5167,8 +5321,8 @@
         </p:nvSpPr>
         <p:spPr>
           <a:xfrm>
-            <a:off x="1645920" y="3163824"/>
-            <a:ext cx="4572000" cy="694944"/>
+            <a:off x="1645920" y="2980944"/>
+            <a:ext cx="4572000" cy="640080"/>
           </a:xfrm>
           <a:prstGeom prst="rect">
             <a:avLst/>
@@ -5203,8 +5357,8 @@
         </p:nvSpPr>
         <p:spPr>
           <a:xfrm>
-            <a:off x="6400800" y="3163824"/>
-            <a:ext cx="4754880" cy="694944"/>
+            <a:off x="6400800" y="2980944"/>
+            <a:ext cx="4754880" cy="640080"/>
           </a:xfrm>
           <a:prstGeom prst="rect">
             <a:avLst/>
@@ -5239,12 +5393,12 @@
         </p:nvSpPr>
         <p:spPr>
           <a:xfrm>
-            <a:off x="640080" y="3931920"/>
-            <a:ext cx="10881360" cy="694944"/>
+            <a:off x="640080" y="3694176"/>
+            <a:ext cx="10881360" cy="640080"/>
           </a:xfrm>
           <a:prstGeom prst="roundRect">
             <a:avLst>
-              <a:gd name="adj" fmla="val 5263"/>
+              <a:gd name="adj" fmla="val 5714"/>
             </a:avLst>
           </a:prstGeom>
           <a:solidFill>
@@ -5268,8 +5422,8 @@
         </p:nvSpPr>
         <p:spPr>
           <a:xfrm>
-            <a:off x="969264" y="3931920"/>
-            <a:ext cx="658368" cy="694944"/>
+            <a:off x="969264" y="3694176"/>
+            <a:ext cx="658368" cy="640080"/>
           </a:xfrm>
           <a:prstGeom prst="rect">
             <a:avLst/>
@@ -5304,8 +5458,8 @@
         </p:nvSpPr>
         <p:spPr>
           <a:xfrm>
-            <a:off x="1645920" y="3931920"/>
-            <a:ext cx="4572000" cy="694944"/>
+            <a:off x="1645920" y="3694176"/>
+            <a:ext cx="4572000" cy="640080"/>
           </a:xfrm>
           <a:prstGeom prst="rect">
             <a:avLst/>
@@ -5340,8 +5494,8 @@
         </p:nvSpPr>
         <p:spPr>
           <a:xfrm>
-            <a:off x="6400800" y="3931920"/>
-            <a:ext cx="4754880" cy="694944"/>
+            <a:off x="6400800" y="3694176"/>
+            <a:ext cx="4754880" cy="640080"/>
           </a:xfrm>
           <a:prstGeom prst="rect">
             <a:avLst/>
@@ -5376,12 +5530,12 @@
         </p:nvSpPr>
         <p:spPr>
           <a:xfrm>
-            <a:off x="640080" y="4700016"/>
-            <a:ext cx="10881360" cy="694944"/>
+            <a:off x="640080" y="4407408"/>
+            <a:ext cx="10881360" cy="640080"/>
           </a:xfrm>
           <a:prstGeom prst="roundRect">
             <a:avLst>
-              <a:gd name="adj" fmla="val 5263"/>
+              <a:gd name="adj" fmla="val 5714"/>
             </a:avLst>
           </a:prstGeom>
           <a:solidFill>
@@ -5405,8 +5559,8 @@
         </p:nvSpPr>
         <p:spPr>
           <a:xfrm>
-            <a:off x="969264" y="4700016"/>
-            <a:ext cx="658368" cy="694944"/>
+            <a:off x="969264" y="4407408"/>
+            <a:ext cx="658368" cy="640080"/>
           </a:xfrm>
           <a:prstGeom prst="rect">
             <a:avLst/>
@@ -5441,8 +5595,8 @@
         </p:nvSpPr>
         <p:spPr>
           <a:xfrm>
-            <a:off x="1645920" y="4700016"/>
-            <a:ext cx="4572000" cy="694944"/>
+            <a:off x="1645920" y="4407408"/>
+            <a:ext cx="4572000" cy="640080"/>
           </a:xfrm>
           <a:prstGeom prst="rect">
             <a:avLst/>
@@ -5477,8 +5631,8 @@
         </p:nvSpPr>
         <p:spPr>
           <a:xfrm>
-            <a:off x="6400800" y="4700016"/>
-            <a:ext cx="4754880" cy="694944"/>
+            <a:off x="6400800" y="4407408"/>
+            <a:ext cx="4754880" cy="640080"/>
           </a:xfrm>
           <a:prstGeom prst="rect">
             <a:avLst/>
@@ -5513,12 +5667,12 @@
         </p:nvSpPr>
         <p:spPr>
           <a:xfrm>
-            <a:off x="640080" y="5504688"/>
-            <a:ext cx="10881360" cy="676656"/>
+            <a:off x="640080" y="5303520"/>
+            <a:ext cx="10881360" cy="932688"/>
           </a:xfrm>
           <a:prstGeom prst="roundRect">
             <a:avLst>
-              <a:gd name="adj" fmla="val 5405"/>
+              <a:gd name="adj" fmla="val 3922"/>
             </a:avLst>
           </a:prstGeom>
           <a:solidFill>
@@ -5542,8 +5696,8 @@
         </p:nvSpPr>
         <p:spPr>
           <a:xfrm>
-            <a:off x="1024128" y="5504688"/>
-            <a:ext cx="7680960" cy="676656"/>
+            <a:off x="1024128" y="5394960"/>
+            <a:ext cx="10113264" cy="329184"/>
           </a:xfrm>
           <a:prstGeom prst="rect">
             <a:avLst/>
@@ -5578,8 +5732,8 @@
         </p:nvSpPr>
         <p:spPr>
           <a:xfrm>
-            <a:off x="8503920" y="5504688"/>
-            <a:ext cx="2926080" cy="676656"/>
+            <a:off x="1024128" y="5779008"/>
+            <a:ext cx="10113264" cy="310896"/>
           </a:xfrm>
           <a:prstGeom prst="rect">
             <a:avLst/>
@@ -5591,18 +5745,18 @@
           <a:bodyPr wrap="square" lIns="0" tIns="0" rIns="0" bIns="0" rtlCol="0" anchor="ctr"/>
           <a:lstStyle/>
           <a:p>
-            <a:pPr algn="r" indent="0" marL="0">
-              <a:buNone/>
-            </a:pPr>
-            <a:r>
-              <a:rPr lang="en-US" sz="1150" dirty="0">
+            <a:pPr algn="l" indent="0" marL="0">
+              <a:buNone/>
+            </a:pPr>
+            <a:r>
+              <a:rPr lang="en-US" sz="1100" dirty="0">
                 <a:solidFill>
                   <a:srgbClr val="97BC62"/>
                 </a:solidFill>
               </a:rPr>
-              <a:t>[ Your name ]  ·  [ phone ]  ·  [ email ]</a:t>
-            </a:r>
-            <a:endParaRPr lang="en-US" sz="1150" dirty="0"/>
+              <a:t>S. Revanth Gopal  ·  94414 88911      Gandra Hemanth Kumar  ·  97055 41348      Sangu Sai Bhargav  ·  90145 51801</a:t>
+            </a:r>
+            <a:endParaRPr lang="en-US" sz="1100" dirty="0"/>
           </a:p>
         </p:txBody>
       </p:sp>

</xml_diff>

<commit_message>
Spell the first presenter's surname out as Samileti
The leading S was a surname, not an initial. Written in full it matches
the other two names on the same block, which are both surname-first and
spelled out, so no name on the deck is now abbreviated while its
neighbours are not.

Co-Authored-By: Claude Opus 5 <noreply@anthropic.com>
Claude-Session: https://claude.ai/code/session_015eVLQErbeRapSeA1fFhwwu
</commit_message>
<xml_diff>
--- a/VegDrop-Nara-Lokesh-Deck.pptx
+++ b/VegDrop-Nara-Lokesh-Deck.pptx
@@ -118,37 +118,37 @@
   <p:extLst>
     <p:ext uri="{521415D9-36F7-43E2-AB2F-B90AF26B5E84}">
       <p14:sectionLst xmlns:p14="http://schemas.microsoft.com/office/powerpoint/2010/main">
-        <p14:section name="Opening" id="{ed980f60-d9dd-68e1-cd70-c366f1846a5d}">
+        <p14:section name="Opening" id="{2b317574-ab01-03bf-c9c5-befc7cc9fc59}">
           <p14:sldIdLst>
             <p14:sldId id="256"/>
           </p14:sldIdLst>
         </p14:section>
-        <p14:section name="The problem" id="{806c2425-e900-c2e4-b35f-bc1005c2a3c6}">
+        <p14:section name="The problem" id="{289a6c31-cee0-12dd-15bc-853363f34d26}">
           <p14:sldIdLst>
             <p14:sldId id="257"/>
             <p14:sldId id="258"/>
           </p14:sldIdLst>
         </p14:section>
-        <p14:section name="The product" id="{85921e75-087b-f2d3-d8d2-3ca202ca0716}">
+        <p14:section name="The product" id="{796f4db9-cbe8-fd43-aacf-d53f7097e07d}">
           <p14:sldIdLst>
             <p14:sldId id="259"/>
             <p14:sldId id="260"/>
             <p14:sldId id="261"/>
           </p14:sldIdLst>
         </p14:section>
-        <p14:section name="Trust and money" id="{c30ad79f-7e59-ab21-0c50-c6618540ae10}">
+        <p14:section name="Trust and money" id="{fc5ee1e7-fa4a-d708-898b-dd751bd9c0be}">
           <p14:sldIdLst>
             <p14:sldId id="262"/>
             <p14:sldId id="263"/>
           </p14:sldIdLst>
         </p14:section>
-        <p14:section name="Impact" id="{95167a4b-6791-3f0b-4aba-70f399a3122f}">
+        <p14:section name="Impact" id="{9ee3a6d3-d0a7-ef2e-a805-eb23ef46c8ac}">
           <p14:sldIdLst>
             <p14:sldId id="264"/>
             <p14:sldId id="265"/>
           </p14:sldIdLst>
         </p14:section>
-        <p14:section name="The ask" id="{368e0b25-d9ed-6a5d-a4cf-389bd93f9438}">
+        <p14:section name="The ask" id="{c5b4d5fe-c72b-ce6a-c95f-af673e15c51e}">
           <p14:sldIdLst>
             <p14:sldId id="266"/>
             <p14:sldId id="267"/>
@@ -3195,7 +3195,7 @@
                   <a:srgbClr val="FFFFFF"/>
                 </a:solidFill>
               </a:rPr>
-              <a:t>S. Revanth Gopal</a:t>
+              <a:t>Samileti Revanth Gopal</a:t>
             </a:r>
             <a:pPr algn="r" indent="0" marL="0">
               <a:lnSpc>
@@ -5754,7 +5754,7 @@
                   <a:srgbClr val="97BC62"/>
                 </a:solidFill>
               </a:rPr>
-              <a:t>S. Revanth Gopal  ·  94414 88911      Gandra Hemanth Kumar  ·  97055 41348      Sangu Sai Bhargav  ·  90145 51801</a:t>
+              <a:t>Samileti Revanth Gopal  ·  94414 88911      Gandra Hemanth Kumar  ·  97055 41348      Sangu Sai Bhargav  ·  90145 51801</a:t>
             </a:r>
             <a:endParaRPr lang="en-US" sz="1100" dirty="0"/>
           </a:p>

</xml_diff>